<commit_message>
新增 GitNexus Wiki 抽取圖（arch-deck Phase 3 測試產物）
- mermaid/.../mmd/wiki/ + png/wiki/：8 張 wiki 內嵌 mermaid 抽取圖
  （wiki 共 9 頁，去重後 8 張；2 張 LLM 語法瑕疵已修：節點標籤加引號）
- PPTX 更新為 15 頁（封面 + 架構 5 + Wiki 分隔 + wiki 8）
- .gitignore 補 .gitnexus（gitnexus 知識圖譜索引不進版控）

Co-Authored-By: Claude Opus 4.8 (1M context) <noreply@anthropic.com>
</commit_message>
<xml_diff>
--- a/mermaid/20260618-freelancer-dashboard/freelancer-dashboard-架構圖表合輯.pptx
+++ b/mermaid/20260618-freelancer-dashboard/freelancer-dashboard-架構圖表合輯.pptx
@@ -11,6 +11,15 @@
     <p:sldId id="259" r:id="rId10"/>
     <p:sldId id="260" r:id="rId11"/>
     <p:sldId id="261" r:id="rId12"/>
+    <p:sldId id="262" r:id="rId13"/>
+    <p:sldId id="263" r:id="rId14"/>
+    <p:sldId id="264" r:id="rId15"/>
+    <p:sldId id="265" r:id="rId16"/>
+    <p:sldId id="266" r:id="rId17"/>
+    <p:sldId id="267" r:id="rId18"/>
+    <p:sldId id="268" r:id="rId19"/>
+    <p:sldId id="269" r:id="rId20"/>
+    <p:sldId id="270" r:id="rId21"/>
   </p:sldIdLst>
   <p:sldSz cx="12191695" cy="6858000" type="screen4x3"/>
   <p:notesSz cx="6858000" cy="9144000"/>
@@ -3199,11 +3208,569 @@
                   <a:srgbClr val="FFFFFF"/>
                 </a:solidFill>
               </a:rPr>
-              <a:t>5 張圖表 ｜ 來源 docs/architecture.md ｜ 2026-06-18</a:t>
-            </a:r>
-          </a:p>
-        </p:txBody>
-      </p:sp>
+              <a:t>架構 5 張 + Wiki 8 張 ｜ 來源 docs/architecture.md + GitNexus Wiki ｜ 2026-06-18</a:t>
+            </a:r>
+          </a:p>
+        </p:txBody>
+      </p:sp>
+    </p:spTree>
+  </p:cSld>
+  <p:clrMapOvr>
+    <a:masterClrMapping/>
+  </p:clrMapOvr>
+</p:sld>
+</file>
+
+<file path=ppt/slides/slide10.xml><?xml version="1.0" encoding="utf-8"?>
+<p:sld xmlns:a="http://schemas.openxmlformats.org/drawingml/2006/main" xmlns:p="http://schemas.openxmlformats.org/presentationml/2006/main" xmlns:r="http://schemas.openxmlformats.org/officeDocument/2006/relationships">
+  <p:cSld>
+    <p:spTree>
+      <p:nvGrpSpPr>
+        <p:cNvPr id="1" name=""/>
+        <p:cNvGrpSpPr/>
+        <p:nvPr/>
+      </p:nvGrpSpPr>
+      <p:grpSpPr/>
+      <p:sp>
+        <p:nvSpPr>
+          <p:cNvPr id="2" name="Rectangle 1"/>
+          <p:cNvSpPr/>
+          <p:nvPr/>
+        </p:nvSpPr>
+        <p:spPr>
+          <a:xfrm>
+            <a:off x="0" y="0"/>
+            <a:ext cx="12191695" cy="685800"/>
+          </a:xfrm>
+          <a:prstGeom prst="rect">
+            <a:avLst/>
+          </a:prstGeom>
+          <a:solidFill>
+            <a:srgbClr val="0055CC"/>
+          </a:solidFill>
+          <a:ln>
+            <a:noFill/>
+          </a:ln>
+        </p:spPr>
+        <p:style>
+          <a:lnRef idx="1">
+            <a:schemeClr val="accent1"/>
+          </a:lnRef>
+          <a:fillRef idx="3">
+            <a:schemeClr val="accent1"/>
+          </a:fillRef>
+          <a:effectRef idx="2">
+            <a:schemeClr val="accent1"/>
+          </a:effectRef>
+          <a:fontRef idx="minor">
+            <a:schemeClr val="lt1"/>
+          </a:fontRef>
+        </p:style>
+        <p:txBody>
+          <a:bodyPr rtlCol="0" anchor="ctr" lIns="365760" tIns="73152"/>
+          <a:lstStyle/>
+          <a:p>
+            <a:pPr algn="ctr"/>
+            <a:r>
+              <a:rPr sz="2400" b="1">
+                <a:solidFill>
+                  <a:srgbClr val="FFFFFF"/>
+                </a:solidFill>
+              </a:rPr>
+              <a:t>Wiki｜database-layer 01</a:t>
+            </a:r>
+          </a:p>
+        </p:txBody>
+      </p:sp>
+      <p:pic>
+        <p:nvPicPr>
+          <p:cNvPr id="3" name="Picture 2" descr="wiki-database-layer-01.png"/>
+          <p:cNvPicPr>
+            <a:picLocks noChangeAspect="1"/>
+          </p:cNvPicPr>
+          <p:nvPr/>
+        </p:nvPicPr>
+        <p:blipFill>
+          <a:blip r:embed="rId2"/>
+          <a:stretch>
+            <a:fillRect/>
+          </a:stretch>
+        </p:blipFill>
+        <p:spPr>
+          <a:xfrm>
+            <a:off x="5033235" y="1005840"/>
+            <a:ext cx="2125223" cy="5532120"/>
+          </a:xfrm>
+          <a:prstGeom prst="rect">
+            <a:avLst/>
+          </a:prstGeom>
+        </p:spPr>
+      </p:pic>
+    </p:spTree>
+  </p:cSld>
+  <p:clrMapOvr>
+    <a:masterClrMapping/>
+  </p:clrMapOvr>
+</p:sld>
+</file>
+
+<file path=ppt/slides/slide11.xml><?xml version="1.0" encoding="utf-8"?>
+<p:sld xmlns:a="http://schemas.openxmlformats.org/drawingml/2006/main" xmlns:p="http://schemas.openxmlformats.org/presentationml/2006/main" xmlns:r="http://schemas.openxmlformats.org/officeDocument/2006/relationships">
+  <p:cSld>
+    <p:spTree>
+      <p:nvGrpSpPr>
+        <p:cNvPr id="1" name=""/>
+        <p:cNvGrpSpPr/>
+        <p:nvPr/>
+      </p:nvGrpSpPr>
+      <p:grpSpPr/>
+      <p:sp>
+        <p:nvSpPr>
+          <p:cNvPr id="2" name="Rectangle 1"/>
+          <p:cNvSpPr/>
+          <p:nvPr/>
+        </p:nvSpPr>
+        <p:spPr>
+          <a:xfrm>
+            <a:off x="0" y="0"/>
+            <a:ext cx="12191695" cy="685800"/>
+          </a:xfrm>
+          <a:prstGeom prst="rect">
+            <a:avLst/>
+          </a:prstGeom>
+          <a:solidFill>
+            <a:srgbClr val="0055CC"/>
+          </a:solidFill>
+          <a:ln>
+            <a:noFill/>
+          </a:ln>
+        </p:spPr>
+        <p:style>
+          <a:lnRef idx="1">
+            <a:schemeClr val="accent1"/>
+          </a:lnRef>
+          <a:fillRef idx="3">
+            <a:schemeClr val="accent1"/>
+          </a:fillRef>
+          <a:effectRef idx="2">
+            <a:schemeClr val="accent1"/>
+          </a:effectRef>
+          <a:fontRef idx="minor">
+            <a:schemeClr val="lt1"/>
+          </a:fontRef>
+        </p:style>
+        <p:txBody>
+          <a:bodyPr rtlCol="0" anchor="ctr" lIns="365760" tIns="73152"/>
+          <a:lstStyle/>
+          <a:p>
+            <a:pPr algn="ctr"/>
+            <a:r>
+              <a:rPr sz="2400" b="1">
+                <a:solidFill>
+                  <a:srgbClr val="FFFFFF"/>
+                </a:solidFill>
+              </a:rPr>
+              <a:t>Wiki｜home 01</a:t>
+            </a:r>
+          </a:p>
+        </p:txBody>
+      </p:sp>
+      <p:pic>
+        <p:nvPicPr>
+          <p:cNvPr id="3" name="Picture 2" descr="wiki-home-01.png"/>
+          <p:cNvPicPr>
+            <a:picLocks noChangeAspect="1"/>
+          </p:cNvPicPr>
+          <p:nvPr/>
+        </p:nvPicPr>
+        <p:blipFill>
+          <a:blip r:embed="rId2"/>
+          <a:stretch>
+            <a:fillRect/>
+          </a:stretch>
+        </p:blipFill>
+        <p:spPr>
+          <a:xfrm>
+            <a:off x="3926694" y="1005840"/>
+            <a:ext cx="4338305" cy="5532120"/>
+          </a:xfrm>
+          <a:prstGeom prst="rect">
+            <a:avLst/>
+          </a:prstGeom>
+        </p:spPr>
+      </p:pic>
+    </p:spTree>
+  </p:cSld>
+  <p:clrMapOvr>
+    <a:masterClrMapping/>
+  </p:clrMapOvr>
+</p:sld>
+</file>
+
+<file path=ppt/slides/slide12.xml><?xml version="1.0" encoding="utf-8"?>
+<p:sld xmlns:a="http://schemas.openxmlformats.org/drawingml/2006/main" xmlns:p="http://schemas.openxmlformats.org/presentationml/2006/main" xmlns:r="http://schemas.openxmlformats.org/officeDocument/2006/relationships">
+  <p:cSld>
+    <p:spTree>
+      <p:nvGrpSpPr>
+        <p:cNvPr id="1" name=""/>
+        <p:cNvGrpSpPr/>
+        <p:nvPr/>
+      </p:nvGrpSpPr>
+      <p:grpSpPr/>
+      <p:sp>
+        <p:nvSpPr>
+          <p:cNvPr id="2" name="Rectangle 1"/>
+          <p:cNvSpPr/>
+          <p:nvPr/>
+        </p:nvSpPr>
+        <p:spPr>
+          <a:xfrm>
+            <a:off x="0" y="0"/>
+            <a:ext cx="12191695" cy="685800"/>
+          </a:xfrm>
+          <a:prstGeom prst="rect">
+            <a:avLst/>
+          </a:prstGeom>
+          <a:solidFill>
+            <a:srgbClr val="0055CC"/>
+          </a:solidFill>
+          <a:ln>
+            <a:noFill/>
+          </a:ln>
+        </p:spPr>
+        <p:style>
+          <a:lnRef idx="1">
+            <a:schemeClr val="accent1"/>
+          </a:lnRef>
+          <a:fillRef idx="3">
+            <a:schemeClr val="accent1"/>
+          </a:fillRef>
+          <a:effectRef idx="2">
+            <a:schemeClr val="accent1"/>
+          </a:effectRef>
+          <a:fontRef idx="minor">
+            <a:schemeClr val="lt1"/>
+          </a:fontRef>
+        </p:style>
+        <p:txBody>
+          <a:bodyPr rtlCol="0" anchor="ctr" lIns="365760" tIns="73152"/>
+          <a:lstStyle/>
+          <a:p>
+            <a:pPr algn="ctr"/>
+            <a:r>
+              <a:rPr sz="2400" b="1">
+                <a:solidFill>
+                  <a:srgbClr val="FFFFFF"/>
+                </a:solidFill>
+              </a:rPr>
+              <a:t>Wiki｜other 01</a:t>
+            </a:r>
+          </a:p>
+        </p:txBody>
+      </p:sp>
+      <p:pic>
+        <p:nvPicPr>
+          <p:cNvPr id="3" name="Picture 2" descr="wiki-other-01.png"/>
+          <p:cNvPicPr>
+            <a:picLocks noChangeAspect="1"/>
+          </p:cNvPicPr>
+          <p:nvPr/>
+        </p:nvPicPr>
+        <p:blipFill>
+          <a:blip r:embed="rId2"/>
+          <a:stretch>
+            <a:fillRect/>
+          </a:stretch>
+        </p:blipFill>
+        <p:spPr>
+          <a:xfrm>
+            <a:off x="4944384" y="1005840"/>
+            <a:ext cx="2302925" cy="5532120"/>
+          </a:xfrm>
+          <a:prstGeom prst="rect">
+            <a:avLst/>
+          </a:prstGeom>
+        </p:spPr>
+      </p:pic>
+    </p:spTree>
+  </p:cSld>
+  <p:clrMapOvr>
+    <a:masterClrMapping/>
+  </p:clrMapOvr>
+</p:sld>
+</file>
+
+<file path=ppt/slides/slide13.xml><?xml version="1.0" encoding="utf-8"?>
+<p:sld xmlns:a="http://schemas.openxmlformats.org/drawingml/2006/main" xmlns:p="http://schemas.openxmlformats.org/presentationml/2006/main" xmlns:r="http://schemas.openxmlformats.org/officeDocument/2006/relationships">
+  <p:cSld>
+    <p:spTree>
+      <p:nvGrpSpPr>
+        <p:cNvPr id="1" name=""/>
+        <p:cNvGrpSpPr/>
+        <p:nvPr/>
+      </p:nvGrpSpPr>
+      <p:grpSpPr/>
+      <p:sp>
+        <p:nvSpPr>
+          <p:cNvPr id="2" name="Rectangle 1"/>
+          <p:cNvSpPr/>
+          <p:nvPr/>
+        </p:nvSpPr>
+        <p:spPr>
+          <a:xfrm>
+            <a:off x="0" y="0"/>
+            <a:ext cx="12191695" cy="685800"/>
+          </a:xfrm>
+          <a:prstGeom prst="rect">
+            <a:avLst/>
+          </a:prstGeom>
+          <a:solidFill>
+            <a:srgbClr val="0055CC"/>
+          </a:solidFill>
+          <a:ln>
+            <a:noFill/>
+          </a:ln>
+        </p:spPr>
+        <p:style>
+          <a:lnRef idx="1">
+            <a:schemeClr val="accent1"/>
+          </a:lnRef>
+          <a:fillRef idx="3">
+            <a:schemeClr val="accent1"/>
+          </a:fillRef>
+          <a:effectRef idx="2">
+            <a:schemeClr val="accent1"/>
+          </a:effectRef>
+          <a:fontRef idx="minor">
+            <a:schemeClr val="lt1"/>
+          </a:fontRef>
+        </p:style>
+        <p:txBody>
+          <a:bodyPr rtlCol="0" anchor="ctr" lIns="365760" tIns="73152"/>
+          <a:lstStyle/>
+          <a:p>
+            <a:pPr algn="ctr"/>
+            <a:r>
+              <a:rPr sz="2400" b="1">
+                <a:solidFill>
+                  <a:srgbClr val="FFFFFF"/>
+                </a:solidFill>
+              </a:rPr>
+              <a:t>Wiki｜overview 01</a:t>
+            </a:r>
+          </a:p>
+        </p:txBody>
+      </p:sp>
+      <p:pic>
+        <p:nvPicPr>
+          <p:cNvPr id="3" name="Picture 2" descr="wiki-overview-01.png"/>
+          <p:cNvPicPr>
+            <a:picLocks noChangeAspect="1"/>
+          </p:cNvPicPr>
+          <p:nvPr/>
+        </p:nvPicPr>
+        <p:blipFill>
+          <a:blip r:embed="rId2"/>
+          <a:stretch>
+            <a:fillRect/>
+          </a:stretch>
+        </p:blipFill>
+        <p:spPr>
+          <a:xfrm>
+            <a:off x="714728" y="1005840"/>
+            <a:ext cx="10762238" cy="5532120"/>
+          </a:xfrm>
+          <a:prstGeom prst="rect">
+            <a:avLst/>
+          </a:prstGeom>
+        </p:spPr>
+      </p:pic>
+    </p:spTree>
+  </p:cSld>
+  <p:clrMapOvr>
+    <a:masterClrMapping/>
+  </p:clrMapOvr>
+</p:sld>
+</file>
+
+<file path=ppt/slides/slide14.xml><?xml version="1.0" encoding="utf-8"?>
+<p:sld xmlns:a="http://schemas.openxmlformats.org/drawingml/2006/main" xmlns:p="http://schemas.openxmlformats.org/presentationml/2006/main" xmlns:r="http://schemas.openxmlformats.org/officeDocument/2006/relationships">
+  <p:cSld>
+    <p:spTree>
+      <p:nvGrpSpPr>
+        <p:cNvPr id="1" name=""/>
+        <p:cNvGrpSpPr/>
+        <p:nvPr/>
+      </p:nvGrpSpPr>
+      <p:grpSpPr/>
+      <p:sp>
+        <p:nvSpPr>
+          <p:cNvPr id="2" name="Rectangle 1"/>
+          <p:cNvSpPr/>
+          <p:nvPr/>
+        </p:nvSpPr>
+        <p:spPr>
+          <a:xfrm>
+            <a:off x="0" y="0"/>
+            <a:ext cx="12191695" cy="685800"/>
+          </a:xfrm>
+          <a:prstGeom prst="rect">
+            <a:avLst/>
+          </a:prstGeom>
+          <a:solidFill>
+            <a:srgbClr val="0055CC"/>
+          </a:solidFill>
+          <a:ln>
+            <a:noFill/>
+          </a:ln>
+        </p:spPr>
+        <p:style>
+          <a:lnRef idx="1">
+            <a:schemeClr val="accent1"/>
+          </a:lnRef>
+          <a:fillRef idx="3">
+            <a:schemeClr val="accent1"/>
+          </a:fillRef>
+          <a:effectRef idx="2">
+            <a:schemeClr val="accent1"/>
+          </a:effectRef>
+          <a:fontRef idx="minor">
+            <a:schemeClr val="lt1"/>
+          </a:fontRef>
+        </p:style>
+        <p:txBody>
+          <a:bodyPr rtlCol="0" anchor="ctr" lIns="365760" tIns="73152"/>
+          <a:lstStyle/>
+          <a:p>
+            <a:pPr algn="ctr"/>
+            <a:r>
+              <a:rPr sz="2400" b="1">
+                <a:solidFill>
+                  <a:srgbClr val="FFFFFF"/>
+                </a:solidFill>
+              </a:rPr>
+              <a:t>Wiki｜ui-components 01</a:t>
+            </a:r>
+          </a:p>
+        </p:txBody>
+      </p:sp>
+      <p:pic>
+        <p:nvPicPr>
+          <p:cNvPr id="3" name="Picture 2" descr="wiki-ui-components-01.png"/>
+          <p:cNvPicPr>
+            <a:picLocks noChangeAspect="1"/>
+          </p:cNvPicPr>
+          <p:nvPr/>
+        </p:nvPicPr>
+        <p:blipFill>
+          <a:blip r:embed="rId2"/>
+          <a:stretch>
+            <a:fillRect/>
+          </a:stretch>
+        </p:blipFill>
+        <p:spPr>
+          <a:xfrm>
+            <a:off x="320039" y="1510199"/>
+            <a:ext cx="11551615" cy="4523400"/>
+          </a:xfrm>
+          <a:prstGeom prst="rect">
+            <a:avLst/>
+          </a:prstGeom>
+        </p:spPr>
+      </p:pic>
+    </p:spTree>
+  </p:cSld>
+  <p:clrMapOvr>
+    <a:masterClrMapping/>
+  </p:clrMapOvr>
+</p:sld>
+</file>
+
+<file path=ppt/slides/slide15.xml><?xml version="1.0" encoding="utf-8"?>
+<p:sld xmlns:a="http://schemas.openxmlformats.org/drawingml/2006/main" xmlns:p="http://schemas.openxmlformats.org/presentationml/2006/main" xmlns:r="http://schemas.openxmlformats.org/officeDocument/2006/relationships">
+  <p:cSld>
+    <p:spTree>
+      <p:nvGrpSpPr>
+        <p:cNvPr id="1" name=""/>
+        <p:cNvGrpSpPr/>
+        <p:nvPr/>
+      </p:nvGrpSpPr>
+      <p:grpSpPr/>
+      <p:sp>
+        <p:nvSpPr>
+          <p:cNvPr id="2" name="Rectangle 1"/>
+          <p:cNvSpPr/>
+          <p:nvPr/>
+        </p:nvSpPr>
+        <p:spPr>
+          <a:xfrm>
+            <a:off x="0" y="0"/>
+            <a:ext cx="12191695" cy="685800"/>
+          </a:xfrm>
+          <a:prstGeom prst="rect">
+            <a:avLst/>
+          </a:prstGeom>
+          <a:solidFill>
+            <a:srgbClr val="0055CC"/>
+          </a:solidFill>
+          <a:ln>
+            <a:noFill/>
+          </a:ln>
+        </p:spPr>
+        <p:style>
+          <a:lnRef idx="1">
+            <a:schemeClr val="accent1"/>
+          </a:lnRef>
+          <a:fillRef idx="3">
+            <a:schemeClr val="accent1"/>
+          </a:fillRef>
+          <a:effectRef idx="2">
+            <a:schemeClr val="accent1"/>
+          </a:effectRef>
+          <a:fontRef idx="minor">
+            <a:schemeClr val="lt1"/>
+          </a:fontRef>
+        </p:style>
+        <p:txBody>
+          <a:bodyPr rtlCol="0" anchor="ctr" lIns="365760" tIns="73152"/>
+          <a:lstStyle/>
+          <a:p>
+            <a:pPr algn="ctr"/>
+            <a:r>
+              <a:rPr sz="2400" b="1">
+                <a:solidFill>
+                  <a:srgbClr val="FFFFFF"/>
+                </a:solidFill>
+              </a:rPr>
+              <a:t>Wiki｜utilities 01</a:t>
+            </a:r>
+          </a:p>
+        </p:txBody>
+      </p:sp>
+      <p:pic>
+        <p:nvPicPr>
+          <p:cNvPr id="3" name="Picture 2" descr="wiki-utilities-01.png"/>
+          <p:cNvPicPr>
+            <a:picLocks noChangeAspect="1"/>
+          </p:cNvPicPr>
+          <p:nvPr/>
+        </p:nvPicPr>
+        <p:blipFill>
+          <a:blip r:embed="rId2"/>
+          <a:stretch>
+            <a:fillRect/>
+          </a:stretch>
+        </p:blipFill>
+        <p:spPr>
+          <a:xfrm>
+            <a:off x="320039" y="3381443"/>
+            <a:ext cx="11551615" cy="780912"/>
+          </a:xfrm>
+          <a:prstGeom prst="rect">
+            <a:avLst/>
+          </a:prstGeom>
+        </p:spPr>
+      </p:pic>
     </p:spTree>
   </p:cSld>
   <p:clrMapOvr>
@@ -3663,6 +4230,287 @@
           <a:xfrm>
             <a:off x="3381716" y="1005840"/>
             <a:ext cx="5428262" cy="5532120"/>
+          </a:xfrm>
+          <a:prstGeom prst="rect">
+            <a:avLst/>
+          </a:prstGeom>
+        </p:spPr>
+      </p:pic>
+    </p:spTree>
+  </p:cSld>
+  <p:clrMapOvr>
+    <a:masterClrMapping/>
+  </p:clrMapOvr>
+</p:sld>
+</file>
+
+<file path=ppt/slides/slide7.xml><?xml version="1.0" encoding="utf-8"?>
+<p:sld xmlns:a="http://schemas.openxmlformats.org/drawingml/2006/main" xmlns:p="http://schemas.openxmlformats.org/presentationml/2006/main" xmlns:r="http://schemas.openxmlformats.org/officeDocument/2006/relationships">
+  <p:cSld>
+    <p:spTree>
+      <p:nvGrpSpPr>
+        <p:cNvPr id="1" name=""/>
+        <p:cNvGrpSpPr/>
+        <p:nvPr/>
+      </p:nvGrpSpPr>
+      <p:grpSpPr/>
+      <p:sp>
+        <p:nvSpPr>
+          <p:cNvPr id="2" name="Rectangle 1"/>
+          <p:cNvSpPr/>
+          <p:nvPr/>
+        </p:nvSpPr>
+        <p:spPr>
+          <a:xfrm>
+            <a:off x="0" y="0"/>
+            <a:ext cx="12191695" cy="6858000"/>
+          </a:xfrm>
+          <a:prstGeom prst="rect">
+            <a:avLst/>
+          </a:prstGeom>
+          <a:solidFill>
+            <a:srgbClr val="0055CC"/>
+          </a:solidFill>
+          <a:ln>
+            <a:noFill/>
+          </a:ln>
+        </p:spPr>
+        <p:style>
+          <a:lnRef idx="1">
+            <a:schemeClr val="accent1"/>
+          </a:lnRef>
+          <a:fillRef idx="3">
+            <a:schemeClr val="accent1"/>
+          </a:fillRef>
+          <a:effectRef idx="2">
+            <a:schemeClr val="accent1"/>
+          </a:effectRef>
+          <a:fontRef idx="minor">
+            <a:schemeClr val="lt1"/>
+          </a:fontRef>
+        </p:style>
+        <p:txBody>
+          <a:bodyPr rtlCol="0" anchor="ctr"/>
+          <a:lstStyle/>
+          <a:p>
+            <a:pPr algn="ctr"/>
+          </a:p>
+        </p:txBody>
+      </p:sp>
+      <p:sp>
+        <p:nvSpPr>
+          <p:cNvPr id="3" name="TextBox 2"/>
+          <p:cNvSpPr txBox="1"/>
+          <p:nvPr/>
+        </p:nvSpPr>
+        <p:spPr>
+          <a:xfrm>
+            <a:off x="914400" y="2743200"/>
+            <a:ext cx="10360152" cy="1371600"/>
+          </a:xfrm>
+          <a:prstGeom prst="rect">
+            <a:avLst/>
+          </a:prstGeom>
+          <a:noFill/>
+        </p:spPr>
+        <p:txBody>
+          <a:bodyPr wrap="none">
+            <a:spAutoFit/>
+          </a:bodyPr>
+          <a:lstStyle/>
+          <a:p>
+            <a:pPr algn="ctr"/>
+            <a:r>
+              <a:rPr sz="4000" b="1">
+                <a:solidFill>
+                  <a:srgbClr val="FFFFFF"/>
+                </a:solidFill>
+              </a:rPr>
+              <a:t>Wiki 補充 — GitNexus 知識圖譜</a:t>
+            </a:r>
+          </a:p>
+        </p:txBody>
+      </p:sp>
+    </p:spTree>
+  </p:cSld>
+  <p:clrMapOvr>
+    <a:masterClrMapping/>
+  </p:clrMapOvr>
+</p:sld>
+</file>
+
+<file path=ppt/slides/slide8.xml><?xml version="1.0" encoding="utf-8"?>
+<p:sld xmlns:a="http://schemas.openxmlformats.org/drawingml/2006/main" xmlns:p="http://schemas.openxmlformats.org/presentationml/2006/main" xmlns:r="http://schemas.openxmlformats.org/officeDocument/2006/relationships">
+  <p:cSld>
+    <p:spTree>
+      <p:nvGrpSpPr>
+        <p:cNvPr id="1" name=""/>
+        <p:cNvGrpSpPr/>
+        <p:nvPr/>
+      </p:nvGrpSpPr>
+      <p:grpSpPr/>
+      <p:sp>
+        <p:nvSpPr>
+          <p:cNvPr id="2" name="Rectangle 1"/>
+          <p:cNvSpPr/>
+          <p:nvPr/>
+        </p:nvSpPr>
+        <p:spPr>
+          <a:xfrm>
+            <a:off x="0" y="0"/>
+            <a:ext cx="12191695" cy="685800"/>
+          </a:xfrm>
+          <a:prstGeom prst="rect">
+            <a:avLst/>
+          </a:prstGeom>
+          <a:solidFill>
+            <a:srgbClr val="0055CC"/>
+          </a:solidFill>
+          <a:ln>
+            <a:noFill/>
+          </a:ln>
+        </p:spPr>
+        <p:style>
+          <a:lnRef idx="1">
+            <a:schemeClr val="accent1"/>
+          </a:lnRef>
+          <a:fillRef idx="3">
+            <a:schemeClr val="accent1"/>
+          </a:fillRef>
+          <a:effectRef idx="2">
+            <a:schemeClr val="accent1"/>
+          </a:effectRef>
+          <a:fontRef idx="minor">
+            <a:schemeClr val="lt1"/>
+          </a:fontRef>
+        </p:style>
+        <p:txBody>
+          <a:bodyPr rtlCol="0" anchor="ctr" lIns="365760" tIns="73152"/>
+          <a:lstStyle/>
+          <a:p>
+            <a:pPr algn="ctr"/>
+            <a:r>
+              <a:rPr sz="2400" b="1">
+                <a:solidFill>
+                  <a:srgbClr val="FFFFFF"/>
+                </a:solidFill>
+              </a:rPr>
+              <a:t>Wiki｜authentication 01</a:t>
+            </a:r>
+          </a:p>
+        </p:txBody>
+      </p:sp>
+      <p:pic>
+        <p:nvPicPr>
+          <p:cNvPr id="3" name="Picture 2" descr="wiki-authentication-01.png"/>
+          <p:cNvPicPr>
+            <a:picLocks noChangeAspect="1"/>
+          </p:cNvPicPr>
+          <p:nvPr/>
+        </p:nvPicPr>
+        <p:blipFill>
+          <a:blip r:embed="rId2"/>
+          <a:stretch>
+            <a:fillRect/>
+          </a:stretch>
+        </p:blipFill>
+        <p:spPr>
+          <a:xfrm>
+            <a:off x="3287139" y="1005840"/>
+            <a:ext cx="5617417" cy="5532120"/>
+          </a:xfrm>
+          <a:prstGeom prst="rect">
+            <a:avLst/>
+          </a:prstGeom>
+        </p:spPr>
+      </p:pic>
+    </p:spTree>
+  </p:cSld>
+  <p:clrMapOvr>
+    <a:masterClrMapping/>
+  </p:clrMapOvr>
+</p:sld>
+</file>
+
+<file path=ppt/slides/slide9.xml><?xml version="1.0" encoding="utf-8"?>
+<p:sld xmlns:a="http://schemas.openxmlformats.org/drawingml/2006/main" xmlns:p="http://schemas.openxmlformats.org/presentationml/2006/main" xmlns:r="http://schemas.openxmlformats.org/officeDocument/2006/relationships">
+  <p:cSld>
+    <p:spTree>
+      <p:nvGrpSpPr>
+        <p:cNvPr id="1" name=""/>
+        <p:cNvGrpSpPr/>
+        <p:nvPr/>
+      </p:nvGrpSpPr>
+      <p:grpSpPr/>
+      <p:sp>
+        <p:nvSpPr>
+          <p:cNvPr id="2" name="Rectangle 1"/>
+          <p:cNvSpPr/>
+          <p:nvPr/>
+        </p:nvSpPr>
+        <p:spPr>
+          <a:xfrm>
+            <a:off x="0" y="0"/>
+            <a:ext cx="12191695" cy="685800"/>
+          </a:xfrm>
+          <a:prstGeom prst="rect">
+            <a:avLst/>
+          </a:prstGeom>
+          <a:solidFill>
+            <a:srgbClr val="0055CC"/>
+          </a:solidFill>
+          <a:ln>
+            <a:noFill/>
+          </a:ln>
+        </p:spPr>
+        <p:style>
+          <a:lnRef idx="1">
+            <a:schemeClr val="accent1"/>
+          </a:lnRef>
+          <a:fillRef idx="3">
+            <a:schemeClr val="accent1"/>
+          </a:fillRef>
+          <a:effectRef idx="2">
+            <a:schemeClr val="accent1"/>
+          </a:effectRef>
+          <a:fontRef idx="minor">
+            <a:schemeClr val="lt1"/>
+          </a:fontRef>
+        </p:style>
+        <p:txBody>
+          <a:bodyPr rtlCol="0" anchor="ctr" lIns="365760" tIns="73152"/>
+          <a:lstStyle/>
+          <a:p>
+            <a:pPr algn="ctr"/>
+            <a:r>
+              <a:rPr sz="2400" b="1">
+                <a:solidFill>
+                  <a:srgbClr val="FFFFFF"/>
+                </a:solidFill>
+              </a:rPr>
+              <a:t>Wiki｜dashboard 01</a:t>
+            </a:r>
+          </a:p>
+        </p:txBody>
+      </p:sp>
+      <p:pic>
+        <p:nvPicPr>
+          <p:cNvPr id="3" name="Picture 2" descr="wiki-dashboard-01.png"/>
+          <p:cNvPicPr>
+            <a:picLocks noChangeAspect="1"/>
+          </p:cNvPicPr>
+          <p:nvPr/>
+        </p:nvPicPr>
+        <p:blipFill>
+          <a:blip r:embed="rId2"/>
+          <a:stretch>
+            <a:fillRect/>
+          </a:stretch>
+        </p:blipFill>
+        <p:spPr>
+          <a:xfrm>
+            <a:off x="444939" y="1005840"/>
+            <a:ext cx="11301815" cy="5532120"/>
           </a:xfrm>
           <a:prstGeom prst="rect">
             <a:avLst/>

</xml_diff>